<commit_message>
Add a verified Sources and go deeper block to every export
Each room keeps sources.json and the room page renders it. Sheets, section exports, chapters, cards, and the study deck end with the same block in HTML, PDF, DOCX, PPTX, and Markdown. Links were opened in October 2026; a page that did not resolve is marked confirm and no URL was invented.

Co-authored-by: CYPHER0X9 <cipher0x9@users.noreply.github.com>
</commit_message>
<xml_diff>
--- a/downloads/five9-study-deck.pptx
+++ b/downloads/five9-study-deck.pptx
@@ -22,6 +22,7 @@
     <p:sldId id="273" r:id="rId18"/>
     <p:sldId id="274" r:id="rId19"/>
     <p:sldId id="275" r:id="rId20"/>
+    <p:sldId id="276" r:id="rId21"/>
   </p:sldIdLst>
   <p:sldSz cx="9144000" cy="5143500"/>
 </p:presentation>
@@ -924,6 +925,75 @@
 </p:sld>
 </file>
 
+<file path=ppt/slides/slide21.xml><?xml version="1.0" encoding="utf-8"?>
+<p:sld xmlns:a="http://schemas.openxmlformats.org/drawingml/2006/main" xmlns:r="http://schemas.openxmlformats.org/officeDocument/2006/relationships" xmlns:p="http://schemas.openxmlformats.org/presentationml/2006/main">
+  <p:cSld>
+    <p:spTree>
+      <p:nvGrpSpPr>
+        <p:cNvPr id="1" name=""/>
+        <p:cNvGrpSpPr/>
+        <p:nvPr/>
+      </p:nvGrpSpPr>
+      <p:grpSpPr>
+        <a:xfrm>
+          <a:off x="0" y="0"/>
+          <a:ext cx="0" cy="0"/>
+          <a:chOff x="0" y="0"/>
+          <a:chExt cx="0" cy="0"/>
+        </a:xfrm>
+      </p:grpSpPr>
+      <p:sp>
+        <p:nvSpPr>
+          <p:cNvPr id="2" name="Title"/>
+          <p:cNvSpPr/>
+          <p:nvPr/>
+        </p:nvSpPr>
+        <p:spPr>
+          <a:xfrm>
+            <a:off x="400000" y="300000"/>
+            <a:ext cx="8000000" cy="800000"/>
+          </a:xfrm>
+        </p:spPr>
+        <p:txBody>
+          <a:bodyPr/>
+          <a:lstStyle/>
+          <a:p>
+            <a:r>
+              <a:t>Sources and go deeper</a:t>
+            </a:r>
+          </a:p>
+        </p:txBody>
+      </p:sp>
+      <p:sp>
+        <p:nvSpPr>
+          <p:cNvPr id="3" name="Body"/>
+          <p:cNvSpPr/>
+          <p:nvPr/>
+        </p:nvSpPr>
+        <p:spPr>
+          <a:xfrm>
+            <a:off x="400000" y="1400000"/>
+            <a:ext cx="8000000" cy="4000000"/>
+          </a:xfrm>
+        </p:spPr>
+        <p:txBody>
+          <a:bodyPr/>
+          <a:lstStyle/>
+          <a:p>
+            <a:r>
+              <a:t>Sources and go deeper Planning your implementation. vendor. https://documentation.five9.com/bundle/basic-admin/page/basic-admin/intro/planning-your-implementation.htm. last checked 2026-10. Technical requirements PDF. vendor. https://documentation-be.five9.com/bundle/five9-technical-requirements/raw/resource/enus/five9-technical-requirements.pdf. last checked 2026-10. IANA service names and port numbers. ports. https://www.iana.org/assignments/service-names-port-numbers/service-names-port-numbers.xhtml. last checked 2026-10. RFC 3261, SIP: Session Initiation Protocol. rfc. https://www.rfc-editor.org/rfc/rfc3261. last checked 2026-10. Interactive voice response. wikipedia. https://en.wikipedia.org/wiki/Interactive_voice_response. last checked 2026-10.</a:t>
+            </a:r>
+          </a:p>
+        </p:txBody>
+      </p:sp>
+    </p:spTree>
+  </p:cSld>
+  <p:clrMapOvr>
+    <a:masterClrMapping/>
+  </p:clrMapOvr>
+</p:sld>
+</file>
+
 <file path=ppt/slides/slide3.xml><?xml version="1.0" encoding="utf-8"?>
 <p:sld xmlns:a="http://schemas.openxmlformats.org/drawingml/2006/main" xmlns:r="http://schemas.openxmlformats.org/officeDocument/2006/relationships" xmlns:p="http://schemas.openxmlformats.org/presentationml/2006/main">
   <p:cSld>

</xml_diff>

<commit_message>
Add skills, workforce, quality, CRM, and ecosystem chapters.
The lab now has 23 tracks and 161 lessons. New pages cite only public sources that opened, and confirm notes stay unlinked.

Co-authored-by: CYPHER0X9 <cipher0x9@users.noreply.github.com>
</commit_message>
<xml_diff>
--- a/downloads/five9-study-deck.pptx
+++ b/downloads/five9-study-deck.pptx
@@ -23,6 +23,11 @@
     <p:sldId id="274" r:id="rId19"/>
     <p:sldId id="275" r:id="rId20"/>
     <p:sldId id="276" r:id="rId21"/>
+    <p:sldId id="277" r:id="rId22"/>
+    <p:sldId id="278" r:id="rId23"/>
+    <p:sldId id="279" r:id="rId24"/>
+    <p:sldId id="280" r:id="rId25"/>
+    <p:sldId id="281" r:id="rId26"/>
   </p:sldIdLst>
   <p:sldSz cx="9144000" cy="5143500"/>
 </p:presentation>
@@ -890,6 +895,351 @@
           <a:lstStyle/>
           <a:p>
             <a:r>
+              <a:t>Skills routing and ACD</a:t>
+            </a:r>
+          </a:p>
+        </p:txBody>
+      </p:sp>
+      <p:sp>
+        <p:nvSpPr>
+          <p:cNvPr id="3" name="Body"/>
+          <p:cNvSpPr/>
+          <p:nvPr/>
+        </p:nvSpPr>
+        <p:spPr>
+          <a:xfrm>
+            <a:off x="400000" y="1400000"/>
+            <a:ext cx="8000000" cy="4000000"/>
+          </a:xfrm>
+        </p:spPr>
+        <p:txBody>
+          <a:bodyPr/>
+          <a:lstStyle/>
+          <a:p>
+            <a:r>
+              <a:t>A skill group is the queue the admin chapter describes. The general word ACD stays on its own page.</a:t>
+            </a:r>
+          </a:p>
+        </p:txBody>
+      </p:sp>
+    </p:spTree>
+  </p:cSld>
+  <p:clrMapOvr>
+    <a:masterClrMapping/>
+  </p:clrMapOvr>
+</p:sld>
+</file>
+
+<file path=ppt/slides/slide21.xml><?xml version="1.0" encoding="utf-8"?>
+<p:sld xmlns:a="http://schemas.openxmlformats.org/drawingml/2006/main" xmlns:r="http://schemas.openxmlformats.org/officeDocument/2006/relationships" xmlns:p="http://schemas.openxmlformats.org/presentationml/2006/main">
+  <p:cSld>
+    <p:spTree>
+      <p:nvGrpSpPr>
+        <p:cNvPr id="1" name=""/>
+        <p:cNvGrpSpPr/>
+        <p:nvPr/>
+      </p:nvGrpSpPr>
+      <p:grpSpPr>
+        <a:xfrm>
+          <a:off x="0" y="0"/>
+          <a:ext cx="0" cy="0"/>
+          <a:chOff x="0" y="0"/>
+          <a:chExt cx="0" cy="0"/>
+        </a:xfrm>
+      </p:grpSpPr>
+      <p:sp>
+        <p:nvSpPr>
+          <p:cNvPr id="2" name="Title"/>
+          <p:cNvSpPr/>
+          <p:nvPr/>
+        </p:nvSpPr>
+        <p:spPr>
+          <a:xfrm>
+            <a:off x="400000" y="300000"/>
+            <a:ext cx="8000000" cy="800000"/>
+          </a:xfrm>
+        </p:spPr>
+        <p:txBody>
+          <a:bodyPr/>
+          <a:lstStyle/>
+          <a:p>
+            <a:r>
+              <a:t>Workforce management</a:t>
+            </a:r>
+          </a:p>
+        </p:txBody>
+      </p:sp>
+      <p:sp>
+        <p:nvSpPr>
+          <p:cNvPr id="3" name="Body"/>
+          <p:cNvSpPr/>
+          <p:nvPr/>
+        </p:nvSpPr>
+        <p:spPr>
+          <a:xfrm>
+            <a:off x="400000" y="1400000"/>
+            <a:ext cx="8000000" cy="4000000"/>
+          </a:xfrm>
+        </p:spPr>
+        <p:txBody>
+          <a:bodyPr/>
+          <a:lstStyle/>
+          <a:p>
+            <a:r>
+              <a:t>WFM is the roster. The pages name the tools and leave the formulas unnamed.</a:t>
+            </a:r>
+          </a:p>
+        </p:txBody>
+      </p:sp>
+    </p:spTree>
+  </p:cSld>
+  <p:clrMapOvr>
+    <a:masterClrMapping/>
+  </p:clrMapOvr>
+</p:sld>
+</file>
+
+<file path=ppt/slides/slide22.xml><?xml version="1.0" encoding="utf-8"?>
+<p:sld xmlns:a="http://schemas.openxmlformats.org/drawingml/2006/main" xmlns:r="http://schemas.openxmlformats.org/officeDocument/2006/relationships" xmlns:p="http://schemas.openxmlformats.org/presentationml/2006/main">
+  <p:cSld>
+    <p:spTree>
+      <p:nvGrpSpPr>
+        <p:cNvPr id="1" name=""/>
+        <p:cNvGrpSpPr/>
+        <p:nvPr/>
+      </p:nvGrpSpPr>
+      <p:grpSpPr>
+        <a:xfrm>
+          <a:off x="0" y="0"/>
+          <a:ext cx="0" cy="0"/>
+          <a:chOff x="0" y="0"/>
+          <a:chExt cx="0" cy="0"/>
+        </a:xfrm>
+      </p:grpSpPr>
+      <p:sp>
+        <p:nvSpPr>
+          <p:cNvPr id="2" name="Title"/>
+          <p:cNvSpPr/>
+          <p:nvPr/>
+        </p:nvSpPr>
+        <p:spPr>
+          <a:xfrm>
+            <a:off x="400000" y="300000"/>
+            <a:ext cx="8000000" cy="800000"/>
+          </a:xfrm>
+        </p:spPr>
+        <p:txBody>
+          <a:bodyPr/>
+          <a:lstStyle/>
+          <a:p>
+            <a:r>
+              <a:t>Quality management and analytics</a:t>
+            </a:r>
+          </a:p>
+        </p:txBody>
+      </p:sp>
+      <p:sp>
+        <p:nvSpPr>
+          <p:cNvPr id="3" name="Body"/>
+          <p:cNvSpPr/>
+          <p:nvPr/>
+        </p:nvSpPr>
+        <p:spPr>
+          <a:xfrm>
+            <a:off x="400000" y="1400000"/>
+            <a:ext cx="8000000" cy="4000000"/>
+          </a:xfrm>
+        </p:spPr>
+        <p:txBody>
+          <a:bodyPr/>
+          <a:lstStyle/>
+          <a:p>
+            <a:r>
+              <a:t>Quality scores a recording against a form. Analytics sweeps interactions. The percents stay on the page that printed them.</a:t>
+            </a:r>
+          </a:p>
+        </p:txBody>
+      </p:sp>
+    </p:spTree>
+  </p:cSld>
+  <p:clrMapOvr>
+    <a:masterClrMapping/>
+  </p:clrMapOvr>
+</p:sld>
+</file>
+
+<file path=ppt/slides/slide23.xml><?xml version="1.0" encoding="utf-8"?>
+<p:sld xmlns:a="http://schemas.openxmlformats.org/drawingml/2006/main" xmlns:r="http://schemas.openxmlformats.org/officeDocument/2006/relationships" xmlns:p="http://schemas.openxmlformats.org/presentationml/2006/main">
+  <p:cSld>
+    <p:spTree>
+      <p:nvGrpSpPr>
+        <p:cNvPr id="1" name=""/>
+        <p:cNvGrpSpPr/>
+        <p:nvPr/>
+      </p:nvGrpSpPr>
+      <p:grpSpPr>
+        <a:xfrm>
+          <a:off x="0" y="0"/>
+          <a:ext cx="0" cy="0"/>
+          <a:chOff x="0" y="0"/>
+          <a:chExt cx="0" cy="0"/>
+        </a:xfrm>
+      </p:grpSpPr>
+      <p:sp>
+        <p:nvSpPr>
+          <p:cNvPr id="2" name="Title"/>
+          <p:cNvSpPr/>
+          <p:nvPr/>
+        </p:nvSpPr>
+        <p:spPr>
+          <a:xfrm>
+            <a:off x="400000" y="300000"/>
+            <a:ext cx="8000000" cy="800000"/>
+          </a:xfrm>
+        </p:spPr>
+        <p:txBody>
+          <a:bodyPr/>
+          <a:lstStyle/>
+          <a:p>
+            <a:r>
+              <a:t>CRM and CTI integrations</a:t>
+            </a:r>
+          </a:p>
+        </p:txBody>
+      </p:sp>
+      <p:sp>
+        <p:nvSpPr>
+          <p:cNvPr id="3" name="Body"/>
+          <p:cNvSpPr/>
+          <p:nvPr/>
+        </p:nvSpPr>
+        <p:spPr>
+          <a:xfrm>
+            <a:off x="400000" y="1400000"/>
+            <a:ext cx="8000000" cy="4000000"/>
+          </a:xfrm>
+        </p:spPr>
+        <p:txBody>
+          <a:bodyPr/>
+          <a:lstStyle/>
+          <a:p>
+            <a:r>
+              <a:t>Public pages name the CRMs and the CTI API. Admin feature lists that did not open stay blank.</a:t>
+            </a:r>
+          </a:p>
+        </p:txBody>
+      </p:sp>
+    </p:spTree>
+  </p:cSld>
+  <p:clrMapOvr>
+    <a:masterClrMapping/>
+  </p:clrMapOvr>
+</p:sld>
+</file>
+
+<file path=ppt/slides/slide24.xml><?xml version="1.0" encoding="utf-8"?>
+<p:sld xmlns:a="http://schemas.openxmlformats.org/drawingml/2006/main" xmlns:r="http://schemas.openxmlformats.org/officeDocument/2006/relationships" xmlns:p="http://schemas.openxmlformats.org/presentationml/2006/main">
+  <p:cSld>
+    <p:spTree>
+      <p:nvGrpSpPr>
+        <p:cNvPr id="1" name=""/>
+        <p:cNvGrpSpPr/>
+        <p:nvPr/>
+      </p:nvGrpSpPr>
+      <p:grpSpPr>
+        <a:xfrm>
+          <a:off x="0" y="0"/>
+          <a:ext cx="0" cy="0"/>
+          <a:chOff x="0" y="0"/>
+          <a:chExt cx="0" cy="0"/>
+        </a:xfrm>
+      </p:grpSpPr>
+      <p:sp>
+        <p:nvSpPr>
+          <p:cNvPr id="2" name="Title"/>
+          <p:cNvSpPr/>
+          <p:nvPr/>
+        </p:nvSpPr>
+        <p:spPr>
+          <a:xfrm>
+            <a:off x="400000" y="300000"/>
+            <a:ext cx="8000000" cy="800000"/>
+          </a:xfrm>
+        </p:spPr>
+        <p:txBody>
+          <a:bodyPr/>
+          <a:lstStyle/>
+          <a:p>
+            <a:r>
+              <a:t>Ecosystem</a:t>
+            </a:r>
+          </a:p>
+        </p:txBody>
+      </p:sp>
+      <p:sp>
+        <p:nvSpPr>
+          <p:cNvPr id="3" name="Body"/>
+          <p:cNvSpPr/>
+          <p:nvPr/>
+        </p:nvSpPr>
+        <p:spPr>
+          <a:xfrm>
+            <a:off x="400000" y="1400000"/>
+            <a:ext cx="8000000" cy="4000000"/>
+          </a:xfrm>
+        </p:spPr>
+        <p:txBody>
+          <a:bodyPr/>
+          <a:lstStyle/>
+          <a:p>
+            <a:r>
+              <a:t>A box needs a page. A line is teaching. A gap stays a gap until a body comes back.</a:t>
+            </a:r>
+          </a:p>
+        </p:txBody>
+      </p:sp>
+    </p:spTree>
+  </p:cSld>
+  <p:clrMapOvr>
+    <a:masterClrMapping/>
+  </p:clrMapOvr>
+</p:sld>
+</file>
+
+<file path=ppt/slides/slide25.xml><?xml version="1.0" encoding="utf-8"?>
+<p:sld xmlns:a="http://schemas.openxmlformats.org/drawingml/2006/main" xmlns:r="http://schemas.openxmlformats.org/officeDocument/2006/relationships" xmlns:p="http://schemas.openxmlformats.org/presentationml/2006/main">
+  <p:cSld>
+    <p:spTree>
+      <p:nvGrpSpPr>
+        <p:cNvPr id="1" name=""/>
+        <p:cNvGrpSpPr/>
+        <p:nvPr/>
+      </p:nvGrpSpPr>
+      <p:grpSpPr>
+        <a:xfrm>
+          <a:off x="0" y="0"/>
+          <a:ext cx="0" cy="0"/>
+          <a:chOff x="0" y="0"/>
+          <a:chExt cx="0" cy="0"/>
+        </a:xfrm>
+      </p:grpSpPr>
+      <p:sp>
+        <p:nvSpPr>
+          <p:cNvPr id="2" name="Title"/>
+          <p:cNvSpPr/>
+          <p:nvPr/>
+        </p:nvSpPr>
+        <p:spPr>
+          <a:xfrm>
+            <a:off x="400000" y="300000"/>
+            <a:ext cx="8000000" cy="800000"/>
+          </a:xfrm>
+        </p:spPr>
+        <p:txBody>
+          <a:bodyPr/>
+          <a:lstStyle/>
+          <a:p>
+            <a:r>
               <a:t>Disclaimer</a:t>
             </a:r>
           </a:p>
@@ -925,7 +1275,7 @@
 </p:sld>
 </file>
 
-<file path=ppt/slides/slide21.xml><?xml version="1.0" encoding="utf-8"?>
+<file path=ppt/slides/slide26.xml><?xml version="1.0" encoding="utf-8"?>
 <p:sld xmlns:a="http://schemas.openxmlformats.org/drawingml/2006/main" xmlns:r="http://schemas.openxmlformats.org/officeDocument/2006/relationships" xmlns:p="http://schemas.openxmlformats.org/presentationml/2006/main">
   <p:cSld>
     <p:spTree>

</xml_diff>

<commit_message>
Add skills, workforce, quality, CRM, and ecosystem chapters. (#8)
The lab now has 23 tracks and 161 lessons. New pages cite only public sources that opened, and confirm notes stay unlinked.

Co-authored-by: Cursor Agent <cursoragent@cursor.com>
Co-authored-by: CYPHER0X9 <cipher0x9@users.noreply.github.com>
</commit_message>
<xml_diff>
--- a/downloads/five9-study-deck.pptx
+++ b/downloads/five9-study-deck.pptx
@@ -23,6 +23,11 @@
     <p:sldId id="274" r:id="rId19"/>
     <p:sldId id="275" r:id="rId20"/>
     <p:sldId id="276" r:id="rId21"/>
+    <p:sldId id="277" r:id="rId22"/>
+    <p:sldId id="278" r:id="rId23"/>
+    <p:sldId id="279" r:id="rId24"/>
+    <p:sldId id="280" r:id="rId25"/>
+    <p:sldId id="281" r:id="rId26"/>
   </p:sldIdLst>
   <p:sldSz cx="9144000" cy="5143500"/>
 </p:presentation>
@@ -890,6 +895,351 @@
           <a:lstStyle/>
           <a:p>
             <a:r>
+              <a:t>Skills routing and ACD</a:t>
+            </a:r>
+          </a:p>
+        </p:txBody>
+      </p:sp>
+      <p:sp>
+        <p:nvSpPr>
+          <p:cNvPr id="3" name="Body"/>
+          <p:cNvSpPr/>
+          <p:nvPr/>
+        </p:nvSpPr>
+        <p:spPr>
+          <a:xfrm>
+            <a:off x="400000" y="1400000"/>
+            <a:ext cx="8000000" cy="4000000"/>
+          </a:xfrm>
+        </p:spPr>
+        <p:txBody>
+          <a:bodyPr/>
+          <a:lstStyle/>
+          <a:p>
+            <a:r>
+              <a:t>A skill group is the queue the admin chapter describes. The general word ACD stays on its own page.</a:t>
+            </a:r>
+          </a:p>
+        </p:txBody>
+      </p:sp>
+    </p:spTree>
+  </p:cSld>
+  <p:clrMapOvr>
+    <a:masterClrMapping/>
+  </p:clrMapOvr>
+</p:sld>
+</file>
+
+<file path=ppt/slides/slide21.xml><?xml version="1.0" encoding="utf-8"?>
+<p:sld xmlns:a="http://schemas.openxmlformats.org/drawingml/2006/main" xmlns:r="http://schemas.openxmlformats.org/officeDocument/2006/relationships" xmlns:p="http://schemas.openxmlformats.org/presentationml/2006/main">
+  <p:cSld>
+    <p:spTree>
+      <p:nvGrpSpPr>
+        <p:cNvPr id="1" name=""/>
+        <p:cNvGrpSpPr/>
+        <p:nvPr/>
+      </p:nvGrpSpPr>
+      <p:grpSpPr>
+        <a:xfrm>
+          <a:off x="0" y="0"/>
+          <a:ext cx="0" cy="0"/>
+          <a:chOff x="0" y="0"/>
+          <a:chExt cx="0" cy="0"/>
+        </a:xfrm>
+      </p:grpSpPr>
+      <p:sp>
+        <p:nvSpPr>
+          <p:cNvPr id="2" name="Title"/>
+          <p:cNvSpPr/>
+          <p:nvPr/>
+        </p:nvSpPr>
+        <p:spPr>
+          <a:xfrm>
+            <a:off x="400000" y="300000"/>
+            <a:ext cx="8000000" cy="800000"/>
+          </a:xfrm>
+        </p:spPr>
+        <p:txBody>
+          <a:bodyPr/>
+          <a:lstStyle/>
+          <a:p>
+            <a:r>
+              <a:t>Workforce management</a:t>
+            </a:r>
+          </a:p>
+        </p:txBody>
+      </p:sp>
+      <p:sp>
+        <p:nvSpPr>
+          <p:cNvPr id="3" name="Body"/>
+          <p:cNvSpPr/>
+          <p:nvPr/>
+        </p:nvSpPr>
+        <p:spPr>
+          <a:xfrm>
+            <a:off x="400000" y="1400000"/>
+            <a:ext cx="8000000" cy="4000000"/>
+          </a:xfrm>
+        </p:spPr>
+        <p:txBody>
+          <a:bodyPr/>
+          <a:lstStyle/>
+          <a:p>
+            <a:r>
+              <a:t>WFM is the roster. The pages name the tools and leave the formulas unnamed.</a:t>
+            </a:r>
+          </a:p>
+        </p:txBody>
+      </p:sp>
+    </p:spTree>
+  </p:cSld>
+  <p:clrMapOvr>
+    <a:masterClrMapping/>
+  </p:clrMapOvr>
+</p:sld>
+</file>
+
+<file path=ppt/slides/slide22.xml><?xml version="1.0" encoding="utf-8"?>
+<p:sld xmlns:a="http://schemas.openxmlformats.org/drawingml/2006/main" xmlns:r="http://schemas.openxmlformats.org/officeDocument/2006/relationships" xmlns:p="http://schemas.openxmlformats.org/presentationml/2006/main">
+  <p:cSld>
+    <p:spTree>
+      <p:nvGrpSpPr>
+        <p:cNvPr id="1" name=""/>
+        <p:cNvGrpSpPr/>
+        <p:nvPr/>
+      </p:nvGrpSpPr>
+      <p:grpSpPr>
+        <a:xfrm>
+          <a:off x="0" y="0"/>
+          <a:ext cx="0" cy="0"/>
+          <a:chOff x="0" y="0"/>
+          <a:chExt cx="0" cy="0"/>
+        </a:xfrm>
+      </p:grpSpPr>
+      <p:sp>
+        <p:nvSpPr>
+          <p:cNvPr id="2" name="Title"/>
+          <p:cNvSpPr/>
+          <p:nvPr/>
+        </p:nvSpPr>
+        <p:spPr>
+          <a:xfrm>
+            <a:off x="400000" y="300000"/>
+            <a:ext cx="8000000" cy="800000"/>
+          </a:xfrm>
+        </p:spPr>
+        <p:txBody>
+          <a:bodyPr/>
+          <a:lstStyle/>
+          <a:p>
+            <a:r>
+              <a:t>Quality management and analytics</a:t>
+            </a:r>
+          </a:p>
+        </p:txBody>
+      </p:sp>
+      <p:sp>
+        <p:nvSpPr>
+          <p:cNvPr id="3" name="Body"/>
+          <p:cNvSpPr/>
+          <p:nvPr/>
+        </p:nvSpPr>
+        <p:spPr>
+          <a:xfrm>
+            <a:off x="400000" y="1400000"/>
+            <a:ext cx="8000000" cy="4000000"/>
+          </a:xfrm>
+        </p:spPr>
+        <p:txBody>
+          <a:bodyPr/>
+          <a:lstStyle/>
+          <a:p>
+            <a:r>
+              <a:t>Quality scores a recording against a form. Analytics sweeps interactions. The percents stay on the page that printed them.</a:t>
+            </a:r>
+          </a:p>
+        </p:txBody>
+      </p:sp>
+    </p:spTree>
+  </p:cSld>
+  <p:clrMapOvr>
+    <a:masterClrMapping/>
+  </p:clrMapOvr>
+</p:sld>
+</file>
+
+<file path=ppt/slides/slide23.xml><?xml version="1.0" encoding="utf-8"?>
+<p:sld xmlns:a="http://schemas.openxmlformats.org/drawingml/2006/main" xmlns:r="http://schemas.openxmlformats.org/officeDocument/2006/relationships" xmlns:p="http://schemas.openxmlformats.org/presentationml/2006/main">
+  <p:cSld>
+    <p:spTree>
+      <p:nvGrpSpPr>
+        <p:cNvPr id="1" name=""/>
+        <p:cNvGrpSpPr/>
+        <p:nvPr/>
+      </p:nvGrpSpPr>
+      <p:grpSpPr>
+        <a:xfrm>
+          <a:off x="0" y="0"/>
+          <a:ext cx="0" cy="0"/>
+          <a:chOff x="0" y="0"/>
+          <a:chExt cx="0" cy="0"/>
+        </a:xfrm>
+      </p:grpSpPr>
+      <p:sp>
+        <p:nvSpPr>
+          <p:cNvPr id="2" name="Title"/>
+          <p:cNvSpPr/>
+          <p:nvPr/>
+        </p:nvSpPr>
+        <p:spPr>
+          <a:xfrm>
+            <a:off x="400000" y="300000"/>
+            <a:ext cx="8000000" cy="800000"/>
+          </a:xfrm>
+        </p:spPr>
+        <p:txBody>
+          <a:bodyPr/>
+          <a:lstStyle/>
+          <a:p>
+            <a:r>
+              <a:t>CRM and CTI integrations</a:t>
+            </a:r>
+          </a:p>
+        </p:txBody>
+      </p:sp>
+      <p:sp>
+        <p:nvSpPr>
+          <p:cNvPr id="3" name="Body"/>
+          <p:cNvSpPr/>
+          <p:nvPr/>
+        </p:nvSpPr>
+        <p:spPr>
+          <a:xfrm>
+            <a:off x="400000" y="1400000"/>
+            <a:ext cx="8000000" cy="4000000"/>
+          </a:xfrm>
+        </p:spPr>
+        <p:txBody>
+          <a:bodyPr/>
+          <a:lstStyle/>
+          <a:p>
+            <a:r>
+              <a:t>Public pages name the CRMs and the CTI API. Admin feature lists that did not open stay blank.</a:t>
+            </a:r>
+          </a:p>
+        </p:txBody>
+      </p:sp>
+    </p:spTree>
+  </p:cSld>
+  <p:clrMapOvr>
+    <a:masterClrMapping/>
+  </p:clrMapOvr>
+</p:sld>
+</file>
+
+<file path=ppt/slides/slide24.xml><?xml version="1.0" encoding="utf-8"?>
+<p:sld xmlns:a="http://schemas.openxmlformats.org/drawingml/2006/main" xmlns:r="http://schemas.openxmlformats.org/officeDocument/2006/relationships" xmlns:p="http://schemas.openxmlformats.org/presentationml/2006/main">
+  <p:cSld>
+    <p:spTree>
+      <p:nvGrpSpPr>
+        <p:cNvPr id="1" name=""/>
+        <p:cNvGrpSpPr/>
+        <p:nvPr/>
+      </p:nvGrpSpPr>
+      <p:grpSpPr>
+        <a:xfrm>
+          <a:off x="0" y="0"/>
+          <a:ext cx="0" cy="0"/>
+          <a:chOff x="0" y="0"/>
+          <a:chExt cx="0" cy="0"/>
+        </a:xfrm>
+      </p:grpSpPr>
+      <p:sp>
+        <p:nvSpPr>
+          <p:cNvPr id="2" name="Title"/>
+          <p:cNvSpPr/>
+          <p:nvPr/>
+        </p:nvSpPr>
+        <p:spPr>
+          <a:xfrm>
+            <a:off x="400000" y="300000"/>
+            <a:ext cx="8000000" cy="800000"/>
+          </a:xfrm>
+        </p:spPr>
+        <p:txBody>
+          <a:bodyPr/>
+          <a:lstStyle/>
+          <a:p>
+            <a:r>
+              <a:t>Ecosystem</a:t>
+            </a:r>
+          </a:p>
+        </p:txBody>
+      </p:sp>
+      <p:sp>
+        <p:nvSpPr>
+          <p:cNvPr id="3" name="Body"/>
+          <p:cNvSpPr/>
+          <p:nvPr/>
+        </p:nvSpPr>
+        <p:spPr>
+          <a:xfrm>
+            <a:off x="400000" y="1400000"/>
+            <a:ext cx="8000000" cy="4000000"/>
+          </a:xfrm>
+        </p:spPr>
+        <p:txBody>
+          <a:bodyPr/>
+          <a:lstStyle/>
+          <a:p>
+            <a:r>
+              <a:t>A box needs a page. A line is teaching. A gap stays a gap until a body comes back.</a:t>
+            </a:r>
+          </a:p>
+        </p:txBody>
+      </p:sp>
+    </p:spTree>
+  </p:cSld>
+  <p:clrMapOvr>
+    <a:masterClrMapping/>
+  </p:clrMapOvr>
+</p:sld>
+</file>
+
+<file path=ppt/slides/slide25.xml><?xml version="1.0" encoding="utf-8"?>
+<p:sld xmlns:a="http://schemas.openxmlformats.org/drawingml/2006/main" xmlns:r="http://schemas.openxmlformats.org/officeDocument/2006/relationships" xmlns:p="http://schemas.openxmlformats.org/presentationml/2006/main">
+  <p:cSld>
+    <p:spTree>
+      <p:nvGrpSpPr>
+        <p:cNvPr id="1" name=""/>
+        <p:cNvGrpSpPr/>
+        <p:nvPr/>
+      </p:nvGrpSpPr>
+      <p:grpSpPr>
+        <a:xfrm>
+          <a:off x="0" y="0"/>
+          <a:ext cx="0" cy="0"/>
+          <a:chOff x="0" y="0"/>
+          <a:chExt cx="0" cy="0"/>
+        </a:xfrm>
+      </p:grpSpPr>
+      <p:sp>
+        <p:nvSpPr>
+          <p:cNvPr id="2" name="Title"/>
+          <p:cNvSpPr/>
+          <p:nvPr/>
+        </p:nvSpPr>
+        <p:spPr>
+          <a:xfrm>
+            <a:off x="400000" y="300000"/>
+            <a:ext cx="8000000" cy="800000"/>
+          </a:xfrm>
+        </p:spPr>
+        <p:txBody>
+          <a:bodyPr/>
+          <a:lstStyle/>
+          <a:p>
+            <a:r>
               <a:t>Disclaimer</a:t>
             </a:r>
           </a:p>
@@ -925,7 +1275,7 @@
 </p:sld>
 </file>
 
-<file path=ppt/slides/slide21.xml><?xml version="1.0" encoding="utf-8"?>
+<file path=ppt/slides/slide26.xml><?xml version="1.0" encoding="utf-8"?>
 <p:sld xmlns:a="http://schemas.openxmlformats.org/drawingml/2006/main" xmlns:r="http://schemas.openxmlformats.org/officeDocument/2006/relationships" xmlns:p="http://schemas.openxmlformats.org/presentationml/2006/main">
   <p:cSld>
     <p:spTree>

</xml_diff>